<commit_message>
docs: fix final demo security slide layout
</commit_message>
<xml_diff>
--- a/docs/final-demo-deck/dist/goalwise-final-demo-high-end-v2.pptx
+++ b/docs/final-demo-deck/dist/goalwise-final-demo-high-end-v2.pptx
@@ -11326,7 +11326,7 @@
                   <a:srgbClr val="0F7A50"/>
                 </a:solidFill>
               </a:rPr>
-              <a:t>DECISION 3</a:t>
+              <a:t>SECURITY BOUNDARY</a:t>
             </a:r>
             <a:endParaRPr lang="en-US" sz="1000" dirty="0"/>
           </a:p>
@@ -11419,16 +11419,16 @@
         </p:nvSpPr>
         <p:spPr>
           <a:xfrm>
-            <a:off x="749808" y="2523744"/>
-            <a:ext cx="4892040" cy="1280160"/>
+            <a:off x="822960" y="2487168"/>
+            <a:ext cx="4892040" cy="960120"/>
           </a:xfrm>
           <a:prstGeom prst="rect">
             <a:avLst/>
           </a:prstGeom>
           <a:solidFill>
-            <a:srgbClr val="F3FBF7"/>
+            <a:srgbClr val="FFFFFF"/>
           </a:solidFill>
-          <a:ln w="17780">
+          <a:ln w="15240">
             <a:solidFill>
               <a:srgbClr val="0F7A50"/>
             </a:solidFill>
@@ -11438,14 +11438,39 @@
       </p:sp>
       <p:sp>
         <p:nvSpPr>
-          <p:cNvPr id="45" name="Text 43"/>
-          <p:cNvSpPr/>
-          <p:nvPr/>
-        </p:nvSpPr>
-        <p:spPr>
-          <a:xfrm>
-            <a:off x="932688" y="2688336"/>
-            <a:ext cx="1463040" cy="164592"/>
+          <p:cNvPr id="45" name="Shape 43"/>
+          <p:cNvSpPr/>
+          <p:nvPr/>
+        </p:nvSpPr>
+        <p:spPr>
+          <a:xfrm>
+            <a:off x="822960" y="2487168"/>
+            <a:ext cx="128016" cy="960120"/>
+          </a:xfrm>
+          <a:prstGeom prst="rect">
+            <a:avLst/>
+          </a:prstGeom>
+          <a:solidFill>
+            <a:srgbClr val="0F7A50"/>
+          </a:solidFill>
+          <a:ln w="12700">
+            <a:solidFill>
+              <a:srgbClr val="0F7A50"/>
+            </a:solidFill>
+            <a:prstDash val="solid"/>
+          </a:ln>
+        </p:spPr>
+      </p:sp>
+      <p:sp>
+        <p:nvSpPr>
+          <p:cNvPr id="46" name="Text 44"/>
+          <p:cNvSpPr/>
+          <p:nvPr/>
+        </p:nvSpPr>
+        <p:spPr>
+          <a:xfrm>
+            <a:off x="1133856" y="2670048"/>
+            <a:ext cx="1234440" cy="219456"/>
           </a:xfrm>
           <a:prstGeom prst="rect">
             <a:avLst/>
@@ -11461,391 +11486,27 @@
               <a:buNone/>
             </a:pPr>
             <a:r>
-              <a:rPr lang="en-US" sz="900" b="1" dirty="0">
+              <a:rPr lang="en-US" sz="1300" b="1" dirty="0">
                 <a:solidFill>
                   <a:srgbClr val="0F7A50"/>
                 </a:solidFill>
               </a:rPr>
-              <a:t>HTTP-ONLY SERVER-SIDE SESSIONS WITH HASHED OPAQUE TOKENS</a:t>
+              <a:t>Session</a:t>
             </a:r>
-            <a:endParaRPr lang="en-US" sz="900" dirty="0"/>
+            <a:endParaRPr lang="en-US" sz="1300" dirty="0"/>
           </a:p>
         </p:txBody>
       </p:sp>
       <p:sp>
         <p:nvSpPr>
-          <p:cNvPr id="46" name="Text 44"/>
-          <p:cNvSpPr/>
-          <p:nvPr/>
-        </p:nvSpPr>
-        <p:spPr>
-          <a:xfrm>
-            <a:off x="950976" y="2999232"/>
-            <a:ext cx="4480560" cy="475488"/>
-          </a:xfrm>
-          <a:prstGeom prst="rect">
-            <a:avLst/>
-          </a:prstGeom>
-          <a:noFill/>
-          <a:ln/>
-        </p:spPr>
-        <p:txBody>
-          <a:bodyPr wrap="square" lIns="0" tIns="0" rIns="0" bIns="0" rtlCol="0" anchor="ctr">
-            <a:normAutofit/>
-          </a:bodyPr>
-          <a:lstStyle/>
-          <a:p>
-            <a:pPr indent="0" marL="0">
-              <a:buNone/>
-            </a:pPr>
-            <a:endParaRPr lang="en-US" sz="1350" dirty="0"/>
-          </a:p>
-        </p:txBody>
-      </p:sp>
-      <p:sp>
-        <p:nvSpPr>
-          <p:cNvPr id="47" name="Shape 45"/>
-          <p:cNvSpPr/>
-          <p:nvPr/>
-        </p:nvSpPr>
-        <p:spPr>
-          <a:xfrm>
-            <a:off x="6190488" y="2523744"/>
-            <a:ext cx="4892040" cy="1280160"/>
-          </a:xfrm>
-          <a:prstGeom prst="rect">
-            <a:avLst/>
-          </a:prstGeom>
-          <a:solidFill>
-            <a:srgbClr val="FFFFFF"/>
-          </a:solidFill>
-          <a:ln w="10160">
-            <a:solidFill>
-              <a:srgbClr val="2563A8"/>
-            </a:solidFill>
-            <a:prstDash val="solid"/>
-          </a:ln>
-        </p:spPr>
-      </p:sp>
-      <p:sp>
-        <p:nvSpPr>
-          <p:cNvPr id="48" name="Text 46"/>
-          <p:cNvSpPr/>
-          <p:nvPr/>
-        </p:nvSpPr>
-        <p:spPr>
-          <a:xfrm>
-            <a:off x="6373368" y="2688336"/>
-            <a:ext cx="1463040" cy="164592"/>
-          </a:xfrm>
-          <a:prstGeom prst="rect">
-            <a:avLst/>
-          </a:prstGeom>
-          <a:noFill/>
-          <a:ln/>
-        </p:spPr>
-        <p:txBody>
-          <a:bodyPr wrap="square" lIns="0" tIns="0" rIns="0" bIns="0" rtlCol="0" anchor="ctr"/>
-          <a:lstStyle/>
-          <a:p>
-            <a:pPr indent="0" marL="0">
-              <a:buNone/>
-            </a:pPr>
-            <a:r>
-              <a:rPr lang="en-US" sz="900" b="1" dirty="0">
-                <a:solidFill>
-                  <a:srgbClr val="2563A8"/>
-                </a:solidFill>
-              </a:rPr>
-              <a:t>CSRF REQUIRED FOR AUTHENTICATED UNSAFE METHODS</a:t>
-            </a:r>
-            <a:endParaRPr lang="en-US" sz="900" dirty="0"/>
-          </a:p>
-        </p:txBody>
-      </p:sp>
-      <p:sp>
-        <p:nvSpPr>
-          <p:cNvPr id="49" name="Text 47"/>
-          <p:cNvSpPr/>
-          <p:nvPr/>
-        </p:nvSpPr>
-        <p:spPr>
-          <a:xfrm>
-            <a:off x="6391656" y="2999232"/>
-            <a:ext cx="4480560" cy="475488"/>
-          </a:xfrm>
-          <a:prstGeom prst="rect">
-            <a:avLst/>
-          </a:prstGeom>
-          <a:noFill/>
-          <a:ln/>
-        </p:spPr>
-        <p:txBody>
-          <a:bodyPr wrap="square" lIns="0" tIns="0" rIns="0" bIns="0" rtlCol="0" anchor="ctr">
-            <a:normAutofit/>
-          </a:bodyPr>
-          <a:lstStyle/>
-          <a:p>
-            <a:pPr indent="0" marL="0">
-              <a:buNone/>
-            </a:pPr>
-            <a:endParaRPr lang="en-US" sz="1350" dirty="0"/>
-          </a:p>
-        </p:txBody>
-      </p:sp>
-      <p:sp>
-        <p:nvSpPr>
-          <p:cNvPr id="50" name="Shape 48"/>
-          <p:cNvSpPr/>
-          <p:nvPr/>
-        </p:nvSpPr>
-        <p:spPr>
-          <a:xfrm>
-            <a:off x="749808" y="4617720"/>
-            <a:ext cx="3154680" cy="1051560"/>
-          </a:xfrm>
-          <a:prstGeom prst="rect">
-            <a:avLst/>
-          </a:prstGeom>
-          <a:solidFill>
-            <a:srgbClr val="FFFFFF"/>
-          </a:solidFill>
-          <a:ln w="10160">
-            <a:solidFill>
-              <a:srgbClr val="E6A83B"/>
-            </a:solidFill>
-            <a:prstDash val="solid"/>
-          </a:ln>
-        </p:spPr>
-      </p:sp>
-      <p:sp>
-        <p:nvSpPr>
-          <p:cNvPr id="51" name="Text 49"/>
-          <p:cNvSpPr/>
-          <p:nvPr/>
-        </p:nvSpPr>
-        <p:spPr>
-          <a:xfrm>
-            <a:off x="932688" y="4782312"/>
-            <a:ext cx="1463040" cy="164592"/>
-          </a:xfrm>
-          <a:prstGeom prst="rect">
-            <a:avLst/>
-          </a:prstGeom>
-          <a:noFill/>
-          <a:ln/>
-        </p:spPr>
-        <p:txBody>
-          <a:bodyPr wrap="square" lIns="0" tIns="0" rIns="0" bIns="0" rtlCol="0" anchor="ctr"/>
-          <a:lstStyle/>
-          <a:p>
-            <a:pPr indent="0" marL="0">
-              <a:buNone/>
-            </a:pPr>
-            <a:r>
-              <a:rPr lang="en-US" sz="900" b="1" dirty="0">
-                <a:solidFill>
-                  <a:srgbClr val="E6A83B"/>
-                </a:solidFill>
-              </a:rPr>
-              <a:t>CROSS-USER PRIVATE RESOURCE ACCESS RETURNS 404</a:t>
-            </a:r>
-            <a:endParaRPr lang="en-US" sz="900" dirty="0"/>
-          </a:p>
-        </p:txBody>
-      </p:sp>
-      <p:sp>
-        <p:nvSpPr>
-          <p:cNvPr id="52" name="Text 50"/>
-          <p:cNvSpPr/>
-          <p:nvPr/>
-        </p:nvSpPr>
-        <p:spPr>
-          <a:xfrm>
-            <a:off x="950976" y="5093208"/>
-            <a:ext cx="2743200" cy="438912"/>
-          </a:xfrm>
-          <a:prstGeom prst="rect">
-            <a:avLst/>
-          </a:prstGeom>
-          <a:noFill/>
-          <a:ln/>
-        </p:spPr>
-        <p:txBody>
-          <a:bodyPr wrap="square" lIns="0" tIns="0" rIns="0" bIns="0" rtlCol="0" anchor="ctr">
-            <a:normAutofit/>
-          </a:bodyPr>
-          <a:lstStyle/>
-          <a:p>
-            <a:pPr indent="0" marL="0">
-              <a:buNone/>
-            </a:pPr>
-            <a:endParaRPr lang="en-US" sz="1120" dirty="0"/>
-          </a:p>
-        </p:txBody>
-      </p:sp>
-      <p:sp>
-        <p:nvSpPr>
-          <p:cNvPr id="53" name="Shape 51"/>
-          <p:cNvSpPr/>
-          <p:nvPr/>
-        </p:nvSpPr>
-        <p:spPr>
-          <a:xfrm>
-            <a:off x="4389120" y="4617720"/>
-            <a:ext cx="3154680" cy="1051560"/>
-          </a:xfrm>
-          <a:prstGeom prst="rect">
-            <a:avLst/>
-          </a:prstGeom>
-          <a:solidFill>
-            <a:srgbClr val="FFFFFF"/>
-          </a:solidFill>
-          <a:ln w="10160">
-            <a:solidFill>
-              <a:srgbClr val="D85F4B"/>
-            </a:solidFill>
-            <a:prstDash val="solid"/>
-          </a:ln>
-        </p:spPr>
-      </p:sp>
-      <p:sp>
-        <p:nvSpPr>
-          <p:cNvPr id="54" name="Text 52"/>
-          <p:cNvSpPr/>
-          <p:nvPr/>
-        </p:nvSpPr>
-        <p:spPr>
-          <a:xfrm>
-            <a:off x="4572000" y="4782312"/>
-            <a:ext cx="1463040" cy="164592"/>
-          </a:xfrm>
-          <a:prstGeom prst="rect">
-            <a:avLst/>
-          </a:prstGeom>
-          <a:noFill/>
-          <a:ln/>
-        </p:spPr>
-        <p:txBody>
-          <a:bodyPr wrap="square" lIns="0" tIns="0" rIns="0" bIns="0" rtlCol="0" anchor="ctr"/>
-          <a:lstStyle/>
-          <a:p>
-            <a:pPr indent="0" marL="0">
-              <a:buNone/>
-            </a:pPr>
-            <a:r>
-              <a:rPr lang="en-US" sz="900" b="1" dirty="0">
-                <a:solidFill>
-                  <a:srgbClr val="D85F4B"/>
-                </a:solidFill>
-              </a:rPr>
-              <a:t>RAILWAY USES SECURE COOKIES, EXPLICIT ORIGIN ALLOWLISTS, AND POSTGRESQL</a:t>
-            </a:r>
-            <a:endParaRPr lang="en-US" sz="900" dirty="0"/>
-          </a:p>
-        </p:txBody>
-      </p:sp>
-      <p:sp>
-        <p:nvSpPr>
-          <p:cNvPr id="55" name="Text 53"/>
-          <p:cNvSpPr/>
-          <p:nvPr/>
-        </p:nvSpPr>
-        <p:spPr>
-          <a:xfrm>
-            <a:off x="4590288" y="5093208"/>
-            <a:ext cx="2743200" cy="438912"/>
-          </a:xfrm>
-          <a:prstGeom prst="rect">
-            <a:avLst/>
-          </a:prstGeom>
-          <a:noFill/>
-          <a:ln/>
-        </p:spPr>
-        <p:txBody>
-          <a:bodyPr wrap="square" lIns="0" tIns="0" rIns="0" bIns="0" rtlCol="0" anchor="ctr">
-            <a:normAutofit/>
-          </a:bodyPr>
-          <a:lstStyle/>
-          <a:p>
-            <a:pPr indent="0" marL="0">
-              <a:buNone/>
-            </a:pPr>
-            <a:endParaRPr lang="en-US" sz="1120" dirty="0"/>
-          </a:p>
-        </p:txBody>
-      </p:sp>
-      <p:sp>
-        <p:nvSpPr>
-          <p:cNvPr id="56" name="Shape 54"/>
-          <p:cNvSpPr/>
-          <p:nvPr/>
-        </p:nvSpPr>
-        <p:spPr>
-          <a:xfrm>
-            <a:off x="8028432" y="4617720"/>
-            <a:ext cx="3154680" cy="1051560"/>
-          </a:xfrm>
-          <a:prstGeom prst="rect">
-            <a:avLst/>
-          </a:prstGeom>
-          <a:solidFill>
-            <a:srgbClr val="FFFFFF"/>
-          </a:solidFill>
-          <a:ln w="10160">
-            <a:solidFill>
-              <a:srgbClr val="0F7A50"/>
-            </a:solidFill>
-            <a:prstDash val="solid"/>
-          </a:ln>
-        </p:spPr>
-      </p:sp>
-      <p:sp>
-        <p:nvSpPr>
-          <p:cNvPr id="57" name="Text 55"/>
-          <p:cNvSpPr/>
-          <p:nvPr/>
-        </p:nvSpPr>
-        <p:spPr>
-          <a:xfrm>
-            <a:off x="8211312" y="4782312"/>
-            <a:ext cx="1463040" cy="164592"/>
-          </a:xfrm>
-          <a:prstGeom prst="rect">
-            <a:avLst/>
-          </a:prstGeom>
-          <a:noFill/>
-          <a:ln/>
-        </p:spPr>
-        <p:txBody>
-          <a:bodyPr wrap="square" lIns="0" tIns="0" rIns="0" bIns="0" rtlCol="0" anchor="ctr"/>
-          <a:lstStyle/>
-          <a:p>
-            <a:pPr indent="0" marL="0">
-              <a:buNone/>
-            </a:pPr>
-            <a:r>
-              <a:rPr lang="en-US" sz="900" b="1" dirty="0">
-                <a:solidFill>
-                  <a:srgbClr val="0F7A50"/>
-                </a:solidFill>
-              </a:rPr>
-              <a:t>FAILURE CASE</a:t>
-            </a:r>
-            <a:endParaRPr lang="en-US" sz="900" dirty="0"/>
-          </a:p>
-        </p:txBody>
-      </p:sp>
-      <p:sp>
-        <p:nvSpPr>
-          <p:cNvPr id="58" name="Text 56"/>
-          <p:cNvSpPr/>
-          <p:nvPr/>
-        </p:nvSpPr>
-        <p:spPr>
-          <a:xfrm>
-            <a:off x="8229600" y="5093208"/>
-            <a:ext cx="2743200" cy="438912"/>
+          <p:cNvPr id="47" name="Text 45"/>
+          <p:cNvSpPr/>
+          <p:nvPr/>
+        </p:nvSpPr>
+        <p:spPr>
+          <a:xfrm>
+            <a:off x="2450592" y="2670048"/>
+            <a:ext cx="2926080" cy="420624"/>
           </a:xfrm>
           <a:prstGeom prst="rect">
             <a:avLst/>
@@ -11863,14 +11524,449 @@
               <a:buNone/>
             </a:pPr>
             <a:r>
-              <a:rPr lang="en-US" sz="1120" dirty="0">
+              <a:rPr lang="en-US" sz="1220" dirty="0">
                 <a:solidFill>
                   <a:srgbClr val="18221F"/>
                 </a:solidFill>
               </a:rPr>
-              <a:t>unauthorized or cross-user access fails without leaking private data</a:t>
+              <a:t>HTTP-only cookie; only a hashed opaque token is stored server-side</a:t>
             </a:r>
-            <a:endParaRPr lang="en-US" sz="1120" dirty="0"/>
+            <a:endParaRPr lang="en-US" sz="1220" dirty="0"/>
+          </a:p>
+        </p:txBody>
+      </p:sp>
+      <p:sp>
+        <p:nvSpPr>
+          <p:cNvPr id="48" name="Shape 46"/>
+          <p:cNvSpPr/>
+          <p:nvPr/>
+        </p:nvSpPr>
+        <p:spPr>
+          <a:xfrm>
+            <a:off x="6263640" y="2487168"/>
+            <a:ext cx="4892040" cy="960120"/>
+          </a:xfrm>
+          <a:prstGeom prst="rect">
+            <a:avLst/>
+          </a:prstGeom>
+          <a:solidFill>
+            <a:srgbClr val="FFFFFF"/>
+          </a:solidFill>
+          <a:ln w="15240">
+            <a:solidFill>
+              <a:srgbClr val="2563A8"/>
+            </a:solidFill>
+            <a:prstDash val="solid"/>
+          </a:ln>
+        </p:spPr>
+      </p:sp>
+      <p:sp>
+        <p:nvSpPr>
+          <p:cNvPr id="49" name="Shape 47"/>
+          <p:cNvSpPr/>
+          <p:nvPr/>
+        </p:nvSpPr>
+        <p:spPr>
+          <a:xfrm>
+            <a:off x="6263640" y="2487168"/>
+            <a:ext cx="128016" cy="960120"/>
+          </a:xfrm>
+          <a:prstGeom prst="rect">
+            <a:avLst/>
+          </a:prstGeom>
+          <a:solidFill>
+            <a:srgbClr val="2563A8"/>
+          </a:solidFill>
+          <a:ln w="12700">
+            <a:solidFill>
+              <a:srgbClr val="2563A8"/>
+            </a:solidFill>
+            <a:prstDash val="solid"/>
+          </a:ln>
+        </p:spPr>
+      </p:sp>
+      <p:sp>
+        <p:nvSpPr>
+          <p:cNvPr id="50" name="Text 48"/>
+          <p:cNvSpPr/>
+          <p:nvPr/>
+        </p:nvSpPr>
+        <p:spPr>
+          <a:xfrm>
+            <a:off x="6574536" y="2670048"/>
+            <a:ext cx="1234440" cy="219456"/>
+          </a:xfrm>
+          <a:prstGeom prst="rect">
+            <a:avLst/>
+          </a:prstGeom>
+          <a:noFill/>
+          <a:ln/>
+        </p:spPr>
+        <p:txBody>
+          <a:bodyPr wrap="square" lIns="0" tIns="0" rIns="0" bIns="0" rtlCol="0" anchor="ctr"/>
+          <a:lstStyle/>
+          <a:p>
+            <a:pPr indent="0" marL="0">
+              <a:buNone/>
+            </a:pPr>
+            <a:r>
+              <a:rPr lang="en-US" sz="1300" b="1" dirty="0">
+                <a:solidFill>
+                  <a:srgbClr val="2563A8"/>
+                </a:solidFill>
+              </a:rPr>
+              <a:t>CSRF</a:t>
+            </a:r>
+            <a:endParaRPr lang="en-US" sz="1300" dirty="0"/>
+          </a:p>
+        </p:txBody>
+      </p:sp>
+      <p:sp>
+        <p:nvSpPr>
+          <p:cNvPr id="51" name="Text 49"/>
+          <p:cNvSpPr/>
+          <p:nvPr/>
+        </p:nvSpPr>
+        <p:spPr>
+          <a:xfrm>
+            <a:off x="7891272" y="2670048"/>
+            <a:ext cx="2926080" cy="420624"/>
+          </a:xfrm>
+          <a:prstGeom prst="rect">
+            <a:avLst/>
+          </a:prstGeom>
+          <a:noFill/>
+          <a:ln/>
+        </p:spPr>
+        <p:txBody>
+          <a:bodyPr wrap="square" lIns="0" tIns="0" rIns="0" bIns="0" rtlCol="0" anchor="ctr">
+            <a:normAutofit/>
+          </a:bodyPr>
+          <a:lstStyle/>
+          <a:p>
+            <a:pPr indent="0" marL="0">
+              <a:buNone/>
+            </a:pPr>
+            <a:r>
+              <a:rPr lang="en-US" sz="1220" dirty="0">
+                <a:solidFill>
+                  <a:srgbClr val="18221F"/>
+                </a:solidFill>
+              </a:rPr>
+              <a:t>Unsafe authenticated methods require a CSRF token</a:t>
+            </a:r>
+            <a:endParaRPr lang="en-US" sz="1220" dirty="0"/>
+          </a:p>
+        </p:txBody>
+      </p:sp>
+      <p:sp>
+        <p:nvSpPr>
+          <p:cNvPr id="52" name="Shape 50"/>
+          <p:cNvSpPr/>
+          <p:nvPr/>
+        </p:nvSpPr>
+        <p:spPr>
+          <a:xfrm>
+            <a:off x="822960" y="3904488"/>
+            <a:ext cx="4892040" cy="960120"/>
+          </a:xfrm>
+          <a:prstGeom prst="rect">
+            <a:avLst/>
+          </a:prstGeom>
+          <a:solidFill>
+            <a:srgbClr val="FFFFFF"/>
+          </a:solidFill>
+          <a:ln w="15240">
+            <a:solidFill>
+              <a:srgbClr val="D85F4B"/>
+            </a:solidFill>
+            <a:prstDash val="solid"/>
+          </a:ln>
+        </p:spPr>
+      </p:sp>
+      <p:sp>
+        <p:nvSpPr>
+          <p:cNvPr id="53" name="Shape 51"/>
+          <p:cNvSpPr/>
+          <p:nvPr/>
+        </p:nvSpPr>
+        <p:spPr>
+          <a:xfrm>
+            <a:off x="822960" y="3904488"/>
+            <a:ext cx="128016" cy="960120"/>
+          </a:xfrm>
+          <a:prstGeom prst="rect">
+            <a:avLst/>
+          </a:prstGeom>
+          <a:solidFill>
+            <a:srgbClr val="D85F4B"/>
+          </a:solidFill>
+          <a:ln w="12700">
+            <a:solidFill>
+              <a:srgbClr val="D85F4B"/>
+            </a:solidFill>
+            <a:prstDash val="solid"/>
+          </a:ln>
+        </p:spPr>
+      </p:sp>
+      <p:sp>
+        <p:nvSpPr>
+          <p:cNvPr id="54" name="Text 52"/>
+          <p:cNvSpPr/>
+          <p:nvPr/>
+        </p:nvSpPr>
+        <p:spPr>
+          <a:xfrm>
+            <a:off x="1133856" y="4087368"/>
+            <a:ext cx="1234440" cy="219456"/>
+          </a:xfrm>
+          <a:prstGeom prst="rect">
+            <a:avLst/>
+          </a:prstGeom>
+          <a:noFill/>
+          <a:ln/>
+        </p:spPr>
+        <p:txBody>
+          <a:bodyPr wrap="square" lIns="0" tIns="0" rIns="0" bIns="0" rtlCol="0" anchor="ctr"/>
+          <a:lstStyle/>
+          <a:p>
+            <a:pPr indent="0" marL="0">
+              <a:buNone/>
+            </a:pPr>
+            <a:r>
+              <a:rPr lang="en-US" sz="1300" b="1" dirty="0">
+                <a:solidFill>
+                  <a:srgbClr val="D85F4B"/>
+                </a:solidFill>
+              </a:rPr>
+              <a:t>Ownership</a:t>
+            </a:r>
+            <a:endParaRPr lang="en-US" sz="1300" dirty="0"/>
+          </a:p>
+        </p:txBody>
+      </p:sp>
+      <p:sp>
+        <p:nvSpPr>
+          <p:cNvPr id="55" name="Text 53"/>
+          <p:cNvSpPr/>
+          <p:nvPr/>
+        </p:nvSpPr>
+        <p:spPr>
+          <a:xfrm>
+            <a:off x="2450592" y="4087368"/>
+            <a:ext cx="2926080" cy="420624"/>
+          </a:xfrm>
+          <a:prstGeom prst="rect">
+            <a:avLst/>
+          </a:prstGeom>
+          <a:noFill/>
+          <a:ln/>
+        </p:spPr>
+        <p:txBody>
+          <a:bodyPr wrap="square" lIns="0" tIns="0" rIns="0" bIns="0" rtlCol="0" anchor="ctr">
+            <a:normAutofit/>
+          </a:bodyPr>
+          <a:lstStyle/>
+          <a:p>
+            <a:pPr indent="0" marL="0">
+              <a:buNone/>
+            </a:pPr>
+            <a:r>
+              <a:rPr lang="en-US" sz="1220" dirty="0">
+                <a:solidFill>
+                  <a:srgbClr val="18221F"/>
+                </a:solidFill>
+              </a:rPr>
+              <a:t>Private cross-user resource access returns 404</a:t>
+            </a:r>
+            <a:endParaRPr lang="en-US" sz="1220" dirty="0"/>
+          </a:p>
+        </p:txBody>
+      </p:sp>
+      <p:sp>
+        <p:nvSpPr>
+          <p:cNvPr id="56" name="Shape 54"/>
+          <p:cNvSpPr/>
+          <p:nvPr/>
+        </p:nvSpPr>
+        <p:spPr>
+          <a:xfrm>
+            <a:off x="6263640" y="3904488"/>
+            <a:ext cx="4892040" cy="960120"/>
+          </a:xfrm>
+          <a:prstGeom prst="rect">
+            <a:avLst/>
+          </a:prstGeom>
+          <a:solidFill>
+            <a:srgbClr val="FFFFFF"/>
+          </a:solidFill>
+          <a:ln w="15240">
+            <a:solidFill>
+              <a:srgbClr val="E6A83B"/>
+            </a:solidFill>
+            <a:prstDash val="solid"/>
+          </a:ln>
+        </p:spPr>
+      </p:sp>
+      <p:sp>
+        <p:nvSpPr>
+          <p:cNvPr id="57" name="Shape 55"/>
+          <p:cNvSpPr/>
+          <p:nvPr/>
+        </p:nvSpPr>
+        <p:spPr>
+          <a:xfrm>
+            <a:off x="6263640" y="3904488"/>
+            <a:ext cx="128016" cy="960120"/>
+          </a:xfrm>
+          <a:prstGeom prst="rect">
+            <a:avLst/>
+          </a:prstGeom>
+          <a:solidFill>
+            <a:srgbClr val="E6A83B"/>
+          </a:solidFill>
+          <a:ln w="12700">
+            <a:solidFill>
+              <a:srgbClr val="E6A83B"/>
+            </a:solidFill>
+            <a:prstDash val="solid"/>
+          </a:ln>
+        </p:spPr>
+      </p:sp>
+      <p:sp>
+        <p:nvSpPr>
+          <p:cNvPr id="58" name="Text 56"/>
+          <p:cNvSpPr/>
+          <p:nvPr/>
+        </p:nvSpPr>
+        <p:spPr>
+          <a:xfrm>
+            <a:off x="6574536" y="4087368"/>
+            <a:ext cx="1234440" cy="219456"/>
+          </a:xfrm>
+          <a:prstGeom prst="rect">
+            <a:avLst/>
+          </a:prstGeom>
+          <a:noFill/>
+          <a:ln/>
+        </p:spPr>
+        <p:txBody>
+          <a:bodyPr wrap="square" lIns="0" tIns="0" rIns="0" bIns="0" rtlCol="0" anchor="ctr"/>
+          <a:lstStyle/>
+          <a:p>
+            <a:pPr indent="0" marL="0">
+              <a:buNone/>
+            </a:pPr>
+            <a:r>
+              <a:rPr lang="en-US" sz="1300" b="1" dirty="0">
+                <a:solidFill>
+                  <a:srgbClr val="E6A83B"/>
+                </a:solidFill>
+              </a:rPr>
+              <a:t>Hosting</a:t>
+            </a:r>
+            <a:endParaRPr lang="en-US" sz="1300" dirty="0"/>
+          </a:p>
+        </p:txBody>
+      </p:sp>
+      <p:sp>
+        <p:nvSpPr>
+          <p:cNvPr id="59" name="Text 57"/>
+          <p:cNvSpPr/>
+          <p:nvPr/>
+        </p:nvSpPr>
+        <p:spPr>
+          <a:xfrm>
+            <a:off x="7891272" y="4087368"/>
+            <a:ext cx="2926080" cy="420624"/>
+          </a:xfrm>
+          <a:prstGeom prst="rect">
+            <a:avLst/>
+          </a:prstGeom>
+          <a:noFill/>
+          <a:ln/>
+        </p:spPr>
+        <p:txBody>
+          <a:bodyPr wrap="square" lIns="0" tIns="0" rIns="0" bIns="0" rtlCol="0" anchor="ctr">
+            <a:normAutofit/>
+          </a:bodyPr>
+          <a:lstStyle/>
+          <a:p>
+            <a:pPr indent="0" marL="0">
+              <a:buNone/>
+            </a:pPr>
+            <a:r>
+              <a:rPr lang="en-US" sz="1220" dirty="0">
+                <a:solidFill>
+                  <a:srgbClr val="18221F"/>
+                </a:solidFill>
+              </a:rPr>
+              <a:t>Railway uses secure cookies, allowlisted origins, and PostgreSQL</a:t>
+            </a:r>
+            <a:endParaRPr lang="en-US" sz="1220" dirty="0"/>
+          </a:p>
+        </p:txBody>
+      </p:sp>
+      <p:sp>
+        <p:nvSpPr>
+          <p:cNvPr id="60" name="Shape 58"/>
+          <p:cNvSpPr/>
+          <p:nvPr/>
+        </p:nvSpPr>
+        <p:spPr>
+          <a:xfrm>
+            <a:off x="960120" y="5440680"/>
+            <a:ext cx="10149840" cy="475488"/>
+          </a:xfrm>
+          <a:prstGeom prst="rect">
+            <a:avLst/>
+          </a:prstGeom>
+          <a:solidFill>
+            <a:srgbClr val="18221F"/>
+          </a:solidFill>
+          <a:ln w="12700">
+            <a:solidFill>
+              <a:srgbClr val="18221F"/>
+            </a:solidFill>
+            <a:prstDash val="solid"/>
+          </a:ln>
+        </p:spPr>
+      </p:sp>
+      <p:sp>
+        <p:nvSpPr>
+          <p:cNvPr id="61" name="Text 59"/>
+          <p:cNvSpPr/>
+          <p:nvPr/>
+        </p:nvSpPr>
+        <p:spPr>
+          <a:xfrm>
+            <a:off x="1143000" y="5596128"/>
+            <a:ext cx="9784080" cy="146304"/>
+          </a:xfrm>
+          <a:prstGeom prst="rect">
+            <a:avLst/>
+          </a:prstGeom>
+          <a:noFill/>
+          <a:ln/>
+        </p:spPr>
+        <p:txBody>
+          <a:bodyPr wrap="square" lIns="0" tIns="0" rIns="0" bIns="0" rtlCol="0" anchor="ctr">
+            <a:normAutofit/>
+          </a:bodyPr>
+          <a:lstStyle/>
+          <a:p>
+            <a:pPr algn="ctr" indent="0" marL="0">
+              <a:buNone/>
+            </a:pPr>
+            <a:r>
+              <a:rPr lang="en-US" sz="1220" b="1" dirty="0">
+                <a:solidFill>
+                  <a:srgbClr val="F6F1E7"/>
+                </a:solidFill>
+              </a:rPr>
+              <a:t>Demo failure case: unauthorized or cross-user access fails without exposing another user's financial data.</a:t>
+            </a:r>
+            <a:endParaRPr lang="en-US" sz="1220" dirty="0"/>
           </a:p>
         </p:txBody>
       </p:sp>

</xml_diff>

<commit_message>
docs: use formal logo in final demo deck
</commit_message>
<xml_diff>
--- a/docs/final-demo-deck/dist/goalwise-final-demo-high-end-v2.pptx
+++ b/docs/final-demo-deck/dist/goalwise-final-demo-high-end-v2.pptx
@@ -2749,120 +2749,33 @@
           </a:p>
         </p:txBody>
       </p:sp>
-      <p:sp>
-        <p:nvSpPr>
-          <p:cNvPr id="46" name="Shape 44"/>
-          <p:cNvSpPr/>
-          <p:nvPr/>
-        </p:nvSpPr>
-        <p:spPr>
-          <a:xfrm>
-            <a:off x="6400800" y="914400"/>
-            <a:ext cx="4023360" cy="4023360"/>
-          </a:xfrm>
-          <a:prstGeom prst="arc">
-            <a:avLst/>
-          </a:prstGeom>
-          <a:noFill/>
-          <a:ln w="27940">
-            <a:solidFill>
-              <a:srgbClr val="8BD8B0">
-                <a:alpha val="92000"/>
-              </a:srgbClr>
-            </a:solidFill>
-            <a:prstDash val="solid"/>
-          </a:ln>
-        </p:spPr>
-      </p:sp>
-      <p:sp>
-        <p:nvSpPr>
-          <p:cNvPr id="47" name="Shape 45"/>
-          <p:cNvSpPr/>
-          <p:nvPr/>
-        </p:nvSpPr>
-        <p:spPr>
-          <a:xfrm>
-            <a:off x="6903720" y="1417320"/>
-            <a:ext cx="3017520" cy="3017520"/>
-          </a:xfrm>
-          <a:prstGeom prst="arc">
-            <a:avLst/>
-          </a:prstGeom>
-          <a:noFill/>
-          <a:ln w="19050">
-            <a:solidFill>
-              <a:srgbClr val="E6A83B">
-                <a:alpha val="85000"/>
-              </a:srgbClr>
-            </a:solidFill>
-            <a:prstDash val="solid"/>
-          </a:ln>
-        </p:spPr>
-      </p:sp>
-      <p:sp>
-        <p:nvSpPr>
-          <p:cNvPr id="48" name="Shape 46"/>
-          <p:cNvSpPr/>
-          <p:nvPr/>
-        </p:nvSpPr>
-        <p:spPr>
-          <a:xfrm>
-            <a:off x="7708392" y="2157984"/>
-            <a:ext cx="1508760" cy="1508760"/>
-          </a:xfrm>
-          <a:prstGeom prst="ellipse">
-            <a:avLst/>
-          </a:prstGeom>
-          <a:solidFill>
-            <a:srgbClr val="172C25"/>
-          </a:solidFill>
-          <a:ln w="16510">
-            <a:solidFill>
-              <a:srgbClr val="0F7A50"/>
-            </a:solidFill>
-            <a:prstDash val="solid"/>
-          </a:ln>
-        </p:spPr>
-      </p:sp>
-      <p:sp>
-        <p:nvSpPr>
-          <p:cNvPr id="49" name="Text 47"/>
-          <p:cNvSpPr/>
-          <p:nvPr/>
-        </p:nvSpPr>
-        <p:spPr>
-          <a:xfrm>
-            <a:off x="7708392" y="2395728"/>
-            <a:ext cx="1508760" cy="512064"/>
-          </a:xfrm>
-          <a:prstGeom prst="rect">
-            <a:avLst/>
-          </a:prstGeom>
-          <a:noFill/>
-          <a:ln/>
-        </p:spPr>
-        <p:txBody>
-          <a:bodyPr wrap="square" lIns="0" tIns="0" rIns="0" bIns="0" rtlCol="0" anchor="ctr"/>
-          <a:lstStyle/>
-          <a:p>
-            <a:pPr algn="ctr" indent="0" marL="0">
-              <a:buNone/>
-            </a:pPr>
-            <a:r>
-              <a:rPr lang="en-US" sz="3400" b="1" dirty="0">
-                <a:solidFill>
-                  <a:srgbClr val="8BD8B0"/>
-                </a:solidFill>
-              </a:rPr>
-              <a:t>$</a:t>
-            </a:r>
-            <a:endParaRPr lang="en-US" sz="3400" dirty="0"/>
-          </a:p>
-        </p:txBody>
-      </p:sp>
-      <p:sp>
-        <p:nvSpPr>
-          <p:cNvPr id="50" name="Shape 48"/>
+      <p:pic>
+        <p:nvPicPr>
+          <p:cNvPr id="46" name="Image 0" descr="/private/tmp/goal-wise-final-deck/docs/final-demo-deck/assets/goalwise-main-logo.png">    </p:cNvPr>
+          <p:cNvPicPr>
+            <a:picLocks noChangeAspect="1"/>
+          </p:cNvPicPr>
+          <p:nvPr/>
+        </p:nvPicPr>
+        <p:blipFill>
+          <a:blip r:embed="rId1"/>
+          <a:stretch>
+            <a:fillRect/>
+          </a:stretch>
+        </p:blipFill>
+        <p:spPr>
+          <a:xfrm>
+            <a:off x="6144768" y="658368"/>
+            <a:ext cx="4709160" cy="4709160"/>
+          </a:xfrm>
+          <a:prstGeom prst="rect">
+            <a:avLst/>
+          </a:prstGeom>
+        </p:spPr>
+      </p:pic>
+      <p:sp>
+        <p:nvSpPr>
+          <p:cNvPr id="47" name="Shape 44"/>
           <p:cNvSpPr/>
           <p:nvPr/>
         </p:nvSpPr>
@@ -2887,7 +2800,7 @@
       </p:sp>
       <p:sp>
         <p:nvSpPr>
-          <p:cNvPr id="51" name="Text 49"/>
+          <p:cNvPr id="48" name="Text 45"/>
           <p:cNvSpPr/>
           <p:nvPr/>
         </p:nvSpPr>
@@ -2923,7 +2836,7 @@
       </p:sp>
       <p:sp>
         <p:nvSpPr>
-          <p:cNvPr id="52" name="Text 50"/>
+          <p:cNvPr id="49" name="Text 46"/>
           <p:cNvSpPr/>
           <p:nvPr/>
         </p:nvSpPr>
@@ -2959,7 +2872,7 @@
       </p:sp>
       <p:sp>
         <p:nvSpPr>
-          <p:cNvPr id="53" name="Shape 51"/>
+          <p:cNvPr id="50" name="Shape 47"/>
           <p:cNvSpPr/>
           <p:nvPr/>
         </p:nvSpPr>
@@ -2984,7 +2897,7 @@
       </p:sp>
       <p:sp>
         <p:nvSpPr>
-          <p:cNvPr id="54" name="Text 52"/>
+          <p:cNvPr id="51" name="Text 48"/>
           <p:cNvSpPr/>
           <p:nvPr/>
         </p:nvSpPr>
@@ -3020,7 +2933,7 @@
       </p:sp>
       <p:sp>
         <p:nvSpPr>
-          <p:cNvPr id="55" name="Text 53"/>
+          <p:cNvPr id="52" name="Text 49"/>
           <p:cNvSpPr/>
           <p:nvPr/>
         </p:nvSpPr>
@@ -3056,7 +2969,7 @@
       </p:sp>
       <p:sp>
         <p:nvSpPr>
-          <p:cNvPr id="56" name="Shape 54"/>
+          <p:cNvPr id="53" name="Shape 50"/>
           <p:cNvSpPr/>
           <p:nvPr/>
         </p:nvSpPr>
@@ -3081,7 +2994,7 @@
       </p:sp>
       <p:sp>
         <p:nvSpPr>
-          <p:cNvPr id="57" name="Text 55"/>
+          <p:cNvPr id="54" name="Text 51"/>
           <p:cNvSpPr/>
           <p:nvPr/>
         </p:nvSpPr>
@@ -3117,7 +3030,7 @@
       </p:sp>
       <p:sp>
         <p:nvSpPr>
-          <p:cNvPr id="58" name="Text 56"/>
+          <p:cNvPr id="55" name="Text 52"/>
           <p:cNvSpPr/>
           <p:nvPr/>
         </p:nvSpPr>
@@ -3153,7 +3066,7 @@
       </p:sp>
       <p:sp>
         <p:nvSpPr>
-          <p:cNvPr id="59" name="Text 57"/>
+          <p:cNvPr id="56" name="Text 53"/>
           <p:cNvSpPr/>
           <p:nvPr/>
         </p:nvSpPr>

</xml_diff>

<commit_message>
docs: make final demo deck project-specific
</commit_message>
<xml_diff>
--- a/docs/final-demo-deck/dist/goalwise-final-demo-high-end-v2.pptx
+++ b/docs/final-demo-deck/dist/goalwise-final-demo-high-end-v2.pptx
@@ -510,7 +510,7 @@
           <a:p>
             <a:r>
               <a:rPr lang="en-US" dirty="0"/>
-              <a:t>0:45. Start with the product question. Explain that the scope is intentionally small: one goal, manual inputs, and a backend calculation the team can explain.</a:t>
+              <a:t>Presenter: Vishal. 0:45. Start with the product question, not the technology. GoalWise is a focused planning workflow: one savings goal, explicit assumptions, and a weekly result that the team can trace back to its inputs.</a:t>
             </a:r>
             <a:endParaRPr lang="en-US" dirty="0"/>
           </a:p>
@@ -598,7 +598,7 @@
           <a:p>
             <a:r>
               <a:rPr lang="en-US" dirty="0"/>
-              <a:t>0:55. Define the product boundary before discussing architecture. The important point is that the implementation is scoped to the planning loop, not general personal finance.</a:t>
+              <a:t>Presenter: Vishal. 0:55. Define the boundary before discussing implementation. The current product is the planning loop, not a general personal-finance system. CSV import and the AI explanation are controlled edges around that loop; bank sync, raw transaction import, and multiple active goals are outside this demo.</a:t>
             </a:r>
             <a:endParaRPr lang="en-US" dirty="0"/>
           </a:p>
@@ -686,7 +686,7 @@
           <a:p>
             <a:r>
               <a:rPr lang="en-US" dirty="0"/>
-              <a:t>1:00. Walk through the request path: browser to API, service validation, pace engine, snapshot, dashboard response. State clearly that React does not duplicate the formula.</a:t>
+              <a:t>Presenter: Nati. 1:00. Walk through the request path: the React UI sends inputs to the versioned FastAPI API; services validate and normalize them; the pure pace engine calculates the result; the database stores the committed snapshot; the dashboard reads the backend response. React formats the number but does not reproduce the formula.</a:t>
             </a:r>
             <a:endParaRPr lang="en-US" dirty="0"/>
           </a:p>
@@ -774,7 +774,7 @@
           <a:p>
             <a:r>
               <a:rPr lang="en-US" dirty="0"/>
-              <a:t>1:00. Present this as the main technical decision. The calculation has to be testable and repeatable because it affects financial guidance.</a:t>
+              <a:t>Presenter: Nati. 1:00. This is the main technical decision. The number has to be reproducible because it is the product's most consequential output. We accepted a narrower formula in exchange for a result we can test, explain, and defend.</a:t>
             </a:r>
             <a:endParaRPr lang="en-US" dirty="0"/>
           </a:p>
@@ -862,7 +862,7 @@
           <a:p>
             <a:r>
               <a:rPr lang="en-US" dirty="0"/>
-              <a:t>0:55. Explain why this matters for review. The app can show what was calculated at a point in time instead of silently changing history.</a:t>
+              <a:t>Presenter: Nati. 0:55. A snapshot gives the dashboard and the explanation a stable reference. When the plan changes, the system creates a new record instead of silently rewriting the old result. That makes the calculation reviewable during the demo and later.</a:t>
             </a:r>
             <a:endParaRPr lang="en-US" dirty="0"/>
           </a:p>
@@ -950,7 +950,7 @@
           <a:p>
             <a:r>
               <a:rPr lang="en-US" dirty="0"/>
-              <a:t>0:55. Explain that security is part of the product contract. Financial data only makes sense if ownership checks are enforced at the backend.</a:t>
+              <a:t>Presenter: Nati. 0:55. Security is part of the product contract, not a deployment footnote. The browser can request a resource, but the backend decides whether the session owns it. We will use invalid CSV as the visible demo failure; the cross-user access tests are the stronger evidence behind the same trust boundary.</a:t>
             </a:r>
             <a:endParaRPr lang="en-US" dirty="0"/>
           </a:p>
@@ -1038,7 +1038,7 @@
           <a:p>
             <a:r>
               <a:rPr lang="en-US" dirty="0"/>
-              <a:t>0:55. Separate runtime AI from development assistance. The runtime feature is explanation only; the financial result comes from pace-v1.</a:t>
+              <a:t>Presenter: Nati. 0:55. The team used AI heavily during implementation, but the specification, boundaries, and review process remained human-guided. At runtime, the model only sees minimized aggregate data from an existing snapshot. It can explain that result, but it cannot calculate, override, or turn it into financial advice.</a:t>
             </a:r>
             <a:endParaRPr lang="en-US" dirty="0"/>
           </a:p>
@@ -1126,7 +1126,7 @@
           <a:p>
             <a:r>
               <a:rPr lang="en-US" dirty="0"/>
-              <a:t>1:00. Tie the test groups back to the architecture. Mention the honest limit: these checks do not prove production load behavior or every future financial scenario.</a:t>
+              <a:t>Presenter: Thanh. 1:00. Tie each evidence group to a system boundary: pace-v1 golden tests for the financial contract; API and cross-user tests for behavior and ownership; migration checks for persistence; frontend checks for the build and user flow; GitHub CI and Railway deployment for delivery. These checks support the demo, but they do not prove production-scale load behavior.</a:t>
             </a:r>
             <a:endParaRPr lang="en-US" dirty="0"/>
           </a:p>
@@ -1214,7 +1214,7 @@
           <a:p>
             <a:r>
               <a:rPr lang="en-US" dirty="0"/>
-              <a:t>0:25. Keep this as the handoff. The next screen should be the app, not another explanation slide.</a:t>
+              <a:t>Presenter: Vishal, then demo operator. 0:25. Hand off directly to the browser. Start at https://goalwise.up.railway.app/register. Use https://staging-goalwise.up.railway.app/register as the fallback. The visible failure is an invalid CSV import: the app should reject it during review rather than changing the plan. Then use seeded data to show the dashboard and generate the AI summary.</a:t>
             </a:r>
             <a:endParaRPr lang="en-US" dirty="0"/>
           </a:p>
@@ -2668,7 +2668,7 @@
                   <a:srgbClr val="8BD8B0"/>
                 </a:solidFill>
               </a:rPr>
-              <a:t>GRADUATE CS FINAL DEMO</a:t>
+              <a:t>GOALWISE / FINAL DEMO</a:t>
             </a:r>
             <a:endParaRPr lang="en-US" sz="900" dirty="0"/>
           </a:p>
@@ -3096,7 +3096,7 @@
                   <a:srgbClr val="D7E4DD"/>
                 </a:solidFill>
               </a:rPr>
-              <a:t>The product answers one question: can the user stay on pace for a target date?  /  The system turns manual assumptions into a weekly safe-to-spend number.</a:t>
+              <a:t>One goal. Explicit assumptions. A result the user can review.  /  Live demo: registration -&gt; setup -&gt; plan -&gt; explanation.</a:t>
             </a:r>
             <a:endParaRPr lang="en-US" sz="1350" dirty="0"/>
           </a:p>
@@ -4206,7 +4206,7 @@
                 <a:ea typeface="Aptos Display" pitchFamily="34" charset="-122"/>
                 <a:cs typeface="Aptos Display" pitchFamily="34" charset="-120"/>
               </a:rPr>
-              <a:t>The MVP keeps the planning problem bounded</a:t>
+              <a:t>We started with one planning question</a:t>
             </a:r>
             <a:endParaRPr lang="en-US" sz="2900" dirty="0"/>
           </a:p>
@@ -4244,7 +4244,7 @@
                   <a:srgbClr val="68766F"/>
                 </a:solidFill>
               </a:rPr>
-              <a:t>The current system supports one active goal and explicit user-entered assumptions.</a:t>
+              <a:t>Can this user reach the target by the target date, and what can they spend this week?</a:t>
             </a:r>
             <a:endParaRPr lang="en-US" sz="1300" dirty="0"/>
           </a:p>
@@ -6194,7 +6194,7 @@
                 <a:ea typeface="Aptos Display" pitchFamily="34" charset="-122"/>
                 <a:cs typeface="Aptos Display" pitchFamily="34" charset="-120"/>
               </a:rPr>
-              <a:t>Data moves through one backend calculation path</a:t>
+              <a:t>The browser collects inputs; the backend decides what they mean</a:t>
             </a:r>
             <a:endParaRPr lang="en-US" sz="2900" dirty="0"/>
           </a:p>
@@ -6232,7 +6232,7 @@
                   <a:srgbClr val="AEBFB6"/>
                 </a:solidFill>
               </a:rPr>
-              <a:t>The frontend captures inputs and renders results; the backend owns the official numbers.</a:t>
+              <a:t>The UI guides the user, while validation, ownership, calculation, and persistence stay server-side.</a:t>
             </a:r>
             <a:endParaRPr lang="en-US" sz="1300" dirty="0"/>
           </a:p>
@@ -7953,7 +7953,7 @@
                   <a:srgbClr val="0F7A50"/>
                 </a:solidFill>
               </a:rPr>
-              <a:t>DECISION 1</a:t>
+              <a:t>CALCULATION DECISION</a:t>
             </a:r>
             <a:endParaRPr lang="en-US" sz="1000" dirty="0"/>
           </a:p>
@@ -7994,7 +7994,7 @@
                 <a:ea typeface="Aptos Display" pitchFamily="34" charset="-122"/>
                 <a:cs typeface="Aptos Display" pitchFamily="34" charset="-120"/>
               </a:rPr>
-              <a:t>Use a deterministic pace engine for financial output</a:t>
+              <a:t>The weekly allowance is calculated in one place</a:t>
             </a:r>
             <a:endParaRPr lang="en-US" sz="2900" dirty="0"/>
           </a:p>
@@ -8032,7 +8032,7 @@
                   <a:srgbClr val="68766F"/>
                 </a:solidFill>
               </a:rPr>
-              <a:t>The same inputs, date, timezone, and formula version produce the same result.</a:t>
+              <a:t>The backend produces safe-to-spend, shortfall, and pace status from versioned inputs.</a:t>
             </a:r>
             <a:endParaRPr lang="en-US" sz="1300" dirty="0"/>
           </a:p>
@@ -8093,7 +8093,7 @@
                   <a:srgbClr val="0F7A50"/>
                 </a:solidFill>
               </a:rPr>
-              <a:t>CLAIM</a:t>
+              <a:t>DECISION</a:t>
             </a:r>
             <a:endParaRPr lang="en-US" sz="900" dirty="0"/>
           </a:p>
@@ -8131,7 +8131,7 @@
                   <a:srgbClr val="18221F"/>
                 </a:solidFill>
               </a:rPr>
-              <a:t>safe-to-spend, shortfall, and pace status come from a deterministic engine.</a:t>
+              <a:t>keep official financial output in pace-v1.</a:t>
             </a:r>
             <a:endParaRPr lang="en-US" sz="1350" dirty="0"/>
           </a:p>
@@ -8230,7 +8230,7 @@
                   <a:srgbClr val="18221F"/>
                 </a:solidFill>
               </a:rPr>
-              <a:t>pace-engine contract and golden tests check stable result behavior.</a:t>
+              <a:t>identical inputs produce the same result; golden tests cover the calculation contract.</a:t>
             </a:r>
             <a:endParaRPr lang="en-US" sz="1350" dirty="0"/>
           </a:p>
@@ -8291,7 +8291,7 @@
                   <a:srgbClr val="E6A83B"/>
                 </a:solidFill>
               </a:rPr>
-              <a:t>REJECTED ALTERNATIVE</a:t>
+              <a:t>ALTERNATIVE REJECTED</a:t>
             </a:r>
             <a:endParaRPr lang="en-US" sz="900" dirty="0"/>
           </a:p>
@@ -8329,7 +8329,7 @@
                   <a:srgbClr val="18221F"/>
                 </a:solidFill>
               </a:rPr>
-              <a:t>AI-generated calculations would be difficult to verify.</a:t>
+              <a:t>an AI-generated number would be harder to reproduce and audit.</a:t>
             </a:r>
             <a:endParaRPr lang="en-US" sz="1120" dirty="0"/>
           </a:p>
@@ -8390,7 +8390,7 @@
                   <a:srgbClr val="D85F4B"/>
                 </a:solidFill>
               </a:rPr>
-              <a:t>RISK</a:t>
+              <a:t>TRADE-OFF</a:t>
             </a:r>
             <a:endParaRPr lang="en-US" sz="900" dirty="0"/>
           </a:p>
@@ -8428,7 +8428,7 @@
                   <a:srgbClr val="18221F"/>
                 </a:solidFill>
               </a:rPr>
-              <a:t>deterministic formulas may be less flexible than open-ended advice.</a:t>
+              <a:t>the formula is narrower than open-ended financial advice.</a:t>
             </a:r>
             <a:endParaRPr lang="en-US" sz="1120" dirty="0"/>
           </a:p>
@@ -8489,7 +8489,7 @@
                   <a:srgbClr val="0F7A50"/>
                 </a:solidFill>
               </a:rPr>
-              <a:t>MITIGATION</a:t>
+              <a:t>CONSEQUENCE</a:t>
             </a:r>
             <a:endParaRPr lang="en-US" sz="900" dirty="0"/>
           </a:p>
@@ -8527,7 +8527,7 @@
                   <a:srgbClr val="18221F"/>
                 </a:solidFill>
               </a:rPr>
-              <a:t>keep explanations separate from the calculation authority.</a:t>
+              <a:t>explanations can add context without changing the number.</a:t>
             </a:r>
             <a:endParaRPr lang="en-US" sz="1120" dirty="0"/>
           </a:p>
@@ -9596,7 +9596,7 @@
                   <a:srgbClr val="0F7A50"/>
                 </a:solidFill>
               </a:rPr>
-              <a:t>DECISION 2</a:t>
+              <a:t>PERSISTENCE DECISION</a:t>
             </a:r>
             <a:endParaRPr lang="en-US" sz="1000" dirty="0"/>
           </a:p>
@@ -9637,7 +9637,7 @@
                 <a:ea typeface="Aptos Display" pitchFamily="34" charset="-122"/>
                 <a:cs typeface="Aptos Display" pitchFamily="34" charset="-120"/>
               </a:rPr>
-              <a:t>Store each committed calculation as a snapshot</a:t>
+              <a:t>A saved plan should explain its own history</a:t>
             </a:r>
             <a:endParaRPr lang="en-US" sz="2900" dirty="0"/>
           </a:p>
@@ -9675,7 +9675,7 @@
                   <a:srgbClr val="68766F"/>
                 </a:solidFill>
               </a:rPr>
-              <a:t>A snapshot records normalized inputs and versioned results for later review.</a:t>
+              <a:t>Each committed calculation records normalized inputs, outputs, and the formula version that produced them.</a:t>
             </a:r>
             <a:endParaRPr lang="en-US" sz="1300" dirty="0"/>
           </a:p>
@@ -9736,7 +9736,7 @@
                   <a:srgbClr val="0F7A50"/>
                 </a:solidFill>
               </a:rPr>
-              <a:t>CLAIM</a:t>
+              <a:t>DECISION</a:t>
             </a:r>
             <a:endParaRPr lang="en-US" sz="900" dirty="0"/>
           </a:p>
@@ -9774,7 +9774,7 @@
                   <a:srgbClr val="18221F"/>
                 </a:solidFill>
               </a:rPr>
-              <a:t>calculations are stored as immutable snapshots after input changes.</a:t>
+              <a:t>write a new immutable snapshot after a committed plan change.</a:t>
             </a:r>
             <a:endParaRPr lang="en-US" sz="1350" dirty="0"/>
           </a:p>
@@ -9873,7 +9873,7 @@
                   <a:srgbClr val="18221F"/>
                 </a:solidFill>
               </a:rPr>
-              <a:t>snapshot schema and repository tests protect stored records.</a:t>
+              <a:t>the snapshot schema stores normalized aggregates and formula_version.</a:t>
             </a:r>
             <a:endParaRPr lang="en-US" sz="1350" dirty="0"/>
           </a:p>
@@ -9934,7 +9934,7 @@
                   <a:srgbClr val="E6A83B"/>
                 </a:solidFill>
               </a:rPr>
-              <a:t>REJECTED ALTERNATIVE</a:t>
+              <a:t>ALTERNATIVE REJECTED</a:t>
             </a:r>
             <a:endParaRPr lang="en-US" sz="900" dirty="0"/>
           </a:p>
@@ -9972,7 +9972,7 @@
                   <a:srgbClr val="18221F"/>
                 </a:solidFill>
               </a:rPr>
-              <a:t>recomputing history would lose what the user saw earlier.</a:t>
+              <a:t>recomputing history would erase what the user saw earlier.</a:t>
             </a:r>
             <a:endParaRPr lang="en-US" sz="1120" dirty="0"/>
           </a:p>
@@ -10033,7 +10033,7 @@
                   <a:srgbClr val="D85F4B"/>
                 </a:solidFill>
               </a:rPr>
-              <a:t>RISK</a:t>
+              <a:t>TRADE-OFF</a:t>
             </a:r>
             <a:endParaRPr lang="en-US" sz="900" dirty="0"/>
           </a:p>
@@ -10071,7 +10071,7 @@
                   <a:srgbClr val="18221F"/>
                 </a:solidFill>
               </a:rPr>
-              <a:t>snapshots add storage and schema discipline.</a:t>
+              <a:t>more records and more schema discipline.</a:t>
             </a:r>
             <a:endParaRPr lang="en-US" sz="1120" dirty="0"/>
           </a:p>
@@ -10132,7 +10132,7 @@
                   <a:srgbClr val="0F7A50"/>
                 </a:solidFill>
               </a:rPr>
-              <a:t>MITIGATION</a:t>
+              <a:t>BOUNDARY</a:t>
             </a:r>
             <a:endParaRPr lang="en-US" sz="900" dirty="0"/>
           </a:p>
@@ -10170,7 +10170,7 @@
                   <a:srgbClr val="18221F"/>
                 </a:solidFill>
               </a:rPr>
-              <a:t>store normalized aggregate inputs, not raw transaction descriptions.</a:t>
+              <a:t>raw transaction descriptions do not enter the durable result.</a:t>
             </a:r>
             <a:endParaRPr lang="en-US" sz="1120" dirty="0"/>
           </a:p>
@@ -11280,7 +11280,7 @@
                 <a:ea typeface="Aptos Display" pitchFamily="34" charset="-122"/>
                 <a:cs typeface="Aptos Display" pitchFamily="34" charset="-120"/>
               </a:rPr>
-              <a:t>Apply ownership and session boundaries consistently</a:t>
+              <a:t>The deployed app does not trust the browser with ownership</a:t>
             </a:r>
             <a:endParaRPr lang="en-US" sz="2900" dirty="0"/>
           </a:p>
@@ -11318,7 +11318,7 @@
                   <a:srgbClr val="68766F"/>
                 </a:solidFill>
               </a:rPr>
-              <a:t>The hosted demo uses the same auth and data-isolation rules as the local system.</a:t>
+              <a:t>Sessions, CSRF checks, and server-side ownership rules protect the same workflow we demo locally.</a:t>
             </a:r>
             <a:endParaRPr lang="en-US" sz="1300" dirty="0"/>
           </a:p>
@@ -12946,7 +12946,7 @@
                   <a:srgbClr val="8BD8B0"/>
                 </a:solidFill>
               </a:rPr>
-              <a:t>AI AND REVIEW</a:t>
+              <a:t>AI BOUNDARY</a:t>
             </a:r>
             <a:endParaRPr lang="en-US" sz="1000" dirty="0"/>
           </a:p>
@@ -12987,7 +12987,7 @@
                 <a:ea typeface="Aptos Display" pitchFamily="34" charset="-122"/>
                 <a:cs typeface="Aptos Display" pitchFamily="34" charset="-120"/>
               </a:rPr>
-              <a:t>AI explains committed results, but does not produce them</a:t>
+              <a:t>The summary is downstream of the calculation</a:t>
             </a:r>
             <a:endParaRPr lang="en-US" sz="2900" dirty="0"/>
           </a:p>
@@ -13025,7 +13025,7 @@
                   <a:srgbClr val="AEBFB6"/>
                 </a:solidFill>
               </a:rPr>
-              <a:t>The planning workflow still works when the AI provider is unavailable.</a:t>
+              <a:t>The model receives a minimized snapshot and writes explanation text; the official numbers remain unchanged.</a:t>
             </a:r>
             <a:endParaRPr lang="en-US" sz="1300" dirty="0"/>
           </a:p>
@@ -14723,7 +14723,7 @@
                   <a:srgbClr val="0F7A50"/>
                 </a:solidFill>
               </a:rPr>
-              <a:t>VERIFICATION</a:t>
+              <a:t>VERIFICATION AND DELIVERY</a:t>
             </a:r>
             <a:endParaRPr lang="en-US" sz="1000" dirty="0"/>
           </a:p>
@@ -14764,7 +14764,7 @@
                 <a:ea typeface="Aptos Display" pitchFamily="34" charset="-122"/>
                 <a:cs typeface="Aptos Display" pitchFamily="34" charset="-120"/>
               </a:rPr>
-              <a:t>Verification follows the system boundaries</a:t>
+              <a:t>We tested the contracts that support the demo</a:t>
             </a:r>
             <a:endParaRPr lang="en-US" sz="2900" dirty="0"/>
           </a:p>
@@ -14802,7 +14802,7 @@
                   <a:srgbClr val="68766F"/>
                 </a:solidFill>
               </a:rPr>
-              <a:t>The checks focus on calculation correctness, data isolation, persistence, and frontend contracts.</a:t>
+              <a:t>The project is deployed through GitHub CI/CD to Railway, with evidence at the calculation, API, UI, and delivery boundaries.</a:t>
             </a:r>
             <a:endParaRPr lang="en-US" sz="1300" dirty="0"/>
           </a:p>
@@ -14810,14 +14810,64 @@
       </p:sp>
       <p:sp>
         <p:nvSpPr>
-          <p:cNvPr id="44" name="Text 42"/>
-          <p:cNvSpPr/>
-          <p:nvPr/>
-        </p:nvSpPr>
-        <p:spPr>
-          <a:xfrm>
-            <a:off x="914400" y="2578608"/>
-            <a:ext cx="1417320" cy="182880"/>
+          <p:cNvPr id="44" name="Shape 42"/>
+          <p:cNvSpPr/>
+          <p:nvPr/>
+        </p:nvSpPr>
+        <p:spPr>
+          <a:xfrm>
+            <a:off x="822960" y="2514600"/>
+            <a:ext cx="3977640" cy="896112"/>
+          </a:xfrm>
+          <a:prstGeom prst="rect">
+            <a:avLst/>
+          </a:prstGeom>
+          <a:solidFill>
+            <a:srgbClr val="FFFFFF"/>
+          </a:solidFill>
+          <a:ln w="13970">
+            <a:solidFill>
+              <a:srgbClr val="0F7A50"/>
+            </a:solidFill>
+            <a:prstDash val="solid"/>
+          </a:ln>
+        </p:spPr>
+      </p:sp>
+      <p:sp>
+        <p:nvSpPr>
+          <p:cNvPr id="45" name="Shape 43"/>
+          <p:cNvSpPr/>
+          <p:nvPr/>
+        </p:nvSpPr>
+        <p:spPr>
+          <a:xfrm>
+            <a:off x="822960" y="2514600"/>
+            <a:ext cx="118872" cy="896112"/>
+          </a:xfrm>
+          <a:prstGeom prst="rect">
+            <a:avLst/>
+          </a:prstGeom>
+          <a:solidFill>
+            <a:srgbClr val="0F7A50"/>
+          </a:solidFill>
+          <a:ln w="12700">
+            <a:solidFill>
+              <a:srgbClr val="0F7A50"/>
+            </a:solidFill>
+            <a:prstDash val="solid"/>
+          </a:ln>
+        </p:spPr>
+      </p:sp>
+      <p:sp>
+        <p:nvSpPr>
+          <p:cNvPr id="46" name="Text 44"/>
+          <p:cNvSpPr/>
+          <p:nvPr/>
+        </p:nvSpPr>
+        <p:spPr>
+          <a:xfrm>
+            <a:off x="1097280" y="2679192"/>
+            <a:ext cx="1325880" cy="182880"/>
           </a:xfrm>
           <a:prstGeom prst="rect">
             <a:avLst/>
@@ -14833,77 +14883,115 @@
               <a:buNone/>
             </a:pPr>
             <a:r>
-              <a:rPr lang="en-US" sz="1200" b="1" dirty="0">
+              <a:rPr lang="en-US" sz="1250" b="1" dirty="0">
+                <a:solidFill>
+                  <a:srgbClr val="0F7A50"/>
+                </a:solidFill>
+              </a:rPr>
+              <a:t>Calculation</a:t>
+            </a:r>
+            <a:endParaRPr lang="en-US" sz="1250" dirty="0"/>
+          </a:p>
+        </p:txBody>
+      </p:sp>
+      <p:sp>
+        <p:nvSpPr>
+          <p:cNvPr id="47" name="Text 45"/>
+          <p:cNvSpPr/>
+          <p:nvPr/>
+        </p:nvSpPr>
+        <p:spPr>
+          <a:xfrm>
+            <a:off x="2395728" y="2679192"/>
+            <a:ext cx="2148840" cy="384048"/>
+          </a:xfrm>
+          <a:prstGeom prst="rect">
+            <a:avLst/>
+          </a:prstGeom>
+          <a:noFill/>
+          <a:ln/>
+        </p:spPr>
+        <p:txBody>
+          <a:bodyPr wrap="square" lIns="0" tIns="0" rIns="0" bIns="0" rtlCol="0" anchor="ctr">
+            <a:normAutofit/>
+          </a:bodyPr>
+          <a:lstStyle/>
+          <a:p>
+            <a:pPr indent="0" marL="0">
+              <a:buNone/>
+            </a:pPr>
+            <a:r>
+              <a:rPr lang="en-US" sz="1120" dirty="0">
                 <a:solidFill>
                   <a:srgbClr val="18221F"/>
                 </a:solidFill>
               </a:rPr>
-              <a:t>pace golden</a:t>
+              <a:t>pace-v1 golden scenarios</a:t>
             </a:r>
-            <a:endParaRPr lang="en-US" sz="1200" dirty="0"/>
+            <a:endParaRPr lang="en-US" sz="1120" dirty="0"/>
           </a:p>
         </p:txBody>
       </p:sp>
       <p:sp>
         <p:nvSpPr>
-          <p:cNvPr id="45" name="Shape 43"/>
-          <p:cNvSpPr/>
-          <p:nvPr/>
-        </p:nvSpPr>
-        <p:spPr>
-          <a:xfrm>
-            <a:off x="2606040" y="2606040"/>
-            <a:ext cx="6858000" cy="164592"/>
+          <p:cNvPr id="48" name="Shape 46"/>
+          <p:cNvSpPr/>
+          <p:nvPr/>
+        </p:nvSpPr>
+        <p:spPr>
+          <a:xfrm>
+            <a:off x="5349240" y="2514600"/>
+            <a:ext cx="3977640" cy="896112"/>
           </a:xfrm>
           <a:prstGeom prst="rect">
             <a:avLst/>
           </a:prstGeom>
           <a:solidFill>
-            <a:srgbClr val="E8EEE9"/>
+            <a:srgbClr val="FFFFFF"/>
+          </a:solidFill>
+          <a:ln w="13970">
+            <a:solidFill>
+              <a:srgbClr val="2563A8"/>
+            </a:solidFill>
+            <a:prstDash val="solid"/>
+          </a:ln>
+        </p:spPr>
+      </p:sp>
+      <p:sp>
+        <p:nvSpPr>
+          <p:cNvPr id="49" name="Shape 47"/>
+          <p:cNvSpPr/>
+          <p:nvPr/>
+        </p:nvSpPr>
+        <p:spPr>
+          <a:xfrm>
+            <a:off x="5349240" y="2514600"/>
+            <a:ext cx="118872" cy="896112"/>
+          </a:xfrm>
+          <a:prstGeom prst="rect">
+            <a:avLst/>
+          </a:prstGeom>
+          <a:solidFill>
+            <a:srgbClr val="2563A8"/>
           </a:solidFill>
           <a:ln w="12700">
             <a:solidFill>
-              <a:srgbClr val="E8EEE9"/>
-            </a:solidFill>
-            <a:prstDash val="solid"/>
-          </a:ln>
-        </p:spPr>
-      </p:sp>
-      <p:sp>
-        <p:nvSpPr>
-          <p:cNvPr id="46" name="Shape 44"/>
-          <p:cNvSpPr/>
-          <p:nvPr/>
-        </p:nvSpPr>
-        <p:spPr>
-          <a:xfrm>
-            <a:off x="2606040" y="2606040"/>
-            <a:ext cx="6309360" cy="164592"/>
-          </a:xfrm>
-          <a:prstGeom prst="rect">
-            <a:avLst/>
-          </a:prstGeom>
-          <a:solidFill>
-            <a:srgbClr val="0F7A50"/>
-          </a:solidFill>
-          <a:ln w="12700">
-            <a:solidFill>
-              <a:srgbClr val="0F7A50"/>
-            </a:solidFill>
-            <a:prstDash val="solid"/>
-          </a:ln>
-        </p:spPr>
-      </p:sp>
-      <p:sp>
-        <p:nvSpPr>
-          <p:cNvPr id="47" name="Text 45"/>
-          <p:cNvSpPr/>
-          <p:nvPr/>
-        </p:nvSpPr>
-        <p:spPr>
-          <a:xfrm>
-            <a:off x="914400" y="3236976"/>
-            <a:ext cx="1417320" cy="182880"/>
+              <a:srgbClr val="2563A8"/>
+            </a:solidFill>
+            <a:prstDash val="solid"/>
+          </a:ln>
+        </p:spPr>
+      </p:sp>
+      <p:sp>
+        <p:nvSpPr>
+          <p:cNvPr id="50" name="Text 48"/>
+          <p:cNvSpPr/>
+          <p:nvPr/>
+        </p:nvSpPr>
+        <p:spPr>
+          <a:xfrm>
+            <a:off x="5623560" y="2679192"/>
+            <a:ext cx="1325880" cy="182880"/>
           </a:xfrm>
           <a:prstGeom prst="rect">
             <a:avLst/>
@@ -14919,77 +15007,115 @@
               <a:buNone/>
             </a:pPr>
             <a:r>
-              <a:rPr lang="en-US" sz="1200" b="1" dirty="0">
+              <a:rPr lang="en-US" sz="1250" b="1" dirty="0">
+                <a:solidFill>
+                  <a:srgbClr val="2563A8"/>
+                </a:solidFill>
+              </a:rPr>
+              <a:t>API</a:t>
+            </a:r>
+            <a:endParaRPr lang="en-US" sz="1250" dirty="0"/>
+          </a:p>
+        </p:txBody>
+      </p:sp>
+      <p:sp>
+        <p:nvSpPr>
+          <p:cNvPr id="51" name="Text 49"/>
+          <p:cNvSpPr/>
+          <p:nvPr/>
+        </p:nvSpPr>
+        <p:spPr>
+          <a:xfrm>
+            <a:off x="6922008" y="2679192"/>
+            <a:ext cx="2148840" cy="384048"/>
+          </a:xfrm>
+          <a:prstGeom prst="rect">
+            <a:avLst/>
+          </a:prstGeom>
+          <a:noFill/>
+          <a:ln/>
+        </p:spPr>
+        <p:txBody>
+          <a:bodyPr wrap="square" lIns="0" tIns="0" rIns="0" bIns="0" rtlCol="0" anchor="ctr">
+            <a:normAutofit/>
+          </a:bodyPr>
+          <a:lstStyle/>
+          <a:p>
+            <a:pPr indent="0" marL="0">
+              <a:buNone/>
+            </a:pPr>
+            <a:r>
+              <a:rPr lang="en-US" sz="1120" dirty="0">
                 <a:solidFill>
                   <a:srgbClr val="18221F"/>
                 </a:solidFill>
               </a:rPr>
-              <a:t>API + auth</a:t>
+              <a:t>auth, ownership, inputs, import, and AI routes</a:t>
             </a:r>
-            <a:endParaRPr lang="en-US" sz="1200" dirty="0"/>
+            <a:endParaRPr lang="en-US" sz="1120" dirty="0"/>
           </a:p>
         </p:txBody>
       </p:sp>
       <p:sp>
         <p:nvSpPr>
-          <p:cNvPr id="48" name="Shape 46"/>
-          <p:cNvSpPr/>
-          <p:nvPr/>
-        </p:nvSpPr>
-        <p:spPr>
-          <a:xfrm>
-            <a:off x="2606040" y="3264408"/>
-            <a:ext cx="6858000" cy="164592"/>
+          <p:cNvPr id="52" name="Shape 50"/>
+          <p:cNvSpPr/>
+          <p:nvPr/>
+        </p:nvSpPr>
+        <p:spPr>
+          <a:xfrm>
+            <a:off x="822960" y="3749040"/>
+            <a:ext cx="3977640" cy="896112"/>
           </a:xfrm>
           <a:prstGeom prst="rect">
             <a:avLst/>
           </a:prstGeom>
           <a:solidFill>
-            <a:srgbClr val="E8EEE9"/>
+            <a:srgbClr val="FFFFFF"/>
+          </a:solidFill>
+          <a:ln w="13970">
+            <a:solidFill>
+              <a:srgbClr val="E6A83B"/>
+            </a:solidFill>
+            <a:prstDash val="solid"/>
+          </a:ln>
+        </p:spPr>
+      </p:sp>
+      <p:sp>
+        <p:nvSpPr>
+          <p:cNvPr id="53" name="Shape 51"/>
+          <p:cNvSpPr/>
+          <p:nvPr/>
+        </p:nvSpPr>
+        <p:spPr>
+          <a:xfrm>
+            <a:off x="822960" y="3749040"/>
+            <a:ext cx="118872" cy="896112"/>
+          </a:xfrm>
+          <a:prstGeom prst="rect">
+            <a:avLst/>
+          </a:prstGeom>
+          <a:solidFill>
+            <a:srgbClr val="E6A83B"/>
           </a:solidFill>
           <a:ln w="12700">
             <a:solidFill>
-              <a:srgbClr val="E8EEE9"/>
-            </a:solidFill>
-            <a:prstDash val="solid"/>
-          </a:ln>
-        </p:spPr>
-      </p:sp>
-      <p:sp>
-        <p:nvSpPr>
-          <p:cNvPr id="49" name="Shape 47"/>
-          <p:cNvSpPr/>
-          <p:nvPr/>
-        </p:nvSpPr>
-        <p:spPr>
-          <a:xfrm>
-            <a:off x="2606040" y="3264408"/>
-            <a:ext cx="5760720" cy="164592"/>
-          </a:xfrm>
-          <a:prstGeom prst="rect">
-            <a:avLst/>
-          </a:prstGeom>
-          <a:solidFill>
-            <a:srgbClr val="2563A8"/>
-          </a:solidFill>
-          <a:ln w="12700">
-            <a:solidFill>
-              <a:srgbClr val="2563A8"/>
-            </a:solidFill>
-            <a:prstDash val="solid"/>
-          </a:ln>
-        </p:spPr>
-      </p:sp>
-      <p:sp>
-        <p:nvSpPr>
-          <p:cNvPr id="50" name="Text 48"/>
-          <p:cNvSpPr/>
-          <p:nvPr/>
-        </p:nvSpPr>
-        <p:spPr>
-          <a:xfrm>
-            <a:off x="914400" y="3895344"/>
-            <a:ext cx="1417320" cy="182880"/>
+              <a:srgbClr val="E6A83B"/>
+            </a:solidFill>
+            <a:prstDash val="solid"/>
+          </a:ln>
+        </p:spPr>
+      </p:sp>
+      <p:sp>
+        <p:nvSpPr>
+          <p:cNvPr id="54" name="Text 52"/>
+          <p:cNvSpPr/>
+          <p:nvPr/>
+        </p:nvSpPr>
+        <p:spPr>
+          <a:xfrm>
+            <a:off x="1097280" y="3913632"/>
+            <a:ext cx="1325880" cy="182880"/>
           </a:xfrm>
           <a:prstGeom prst="rect">
             <a:avLst/>
@@ -15005,77 +15131,115 @@
               <a:buNone/>
             </a:pPr>
             <a:r>
-              <a:rPr lang="en-US" sz="1200" b="1" dirty="0">
+              <a:rPr lang="en-US" sz="1250" b="1" dirty="0">
+                <a:solidFill>
+                  <a:srgbClr val="E6A83B"/>
+                </a:solidFill>
+              </a:rPr>
+              <a:t>Persistence</a:t>
+            </a:r>
+            <a:endParaRPr lang="en-US" sz="1250" dirty="0"/>
+          </a:p>
+        </p:txBody>
+      </p:sp>
+      <p:sp>
+        <p:nvSpPr>
+          <p:cNvPr id="55" name="Text 53"/>
+          <p:cNvSpPr/>
+          <p:nvPr/>
+        </p:nvSpPr>
+        <p:spPr>
+          <a:xfrm>
+            <a:off x="2395728" y="3913632"/>
+            <a:ext cx="2148840" cy="384048"/>
+          </a:xfrm>
+          <a:prstGeom prst="rect">
+            <a:avLst/>
+          </a:prstGeom>
+          <a:noFill/>
+          <a:ln/>
+        </p:spPr>
+        <p:txBody>
+          <a:bodyPr wrap="square" lIns="0" tIns="0" rIns="0" bIns="0" rtlCol="0" anchor="ctr">
+            <a:normAutofit/>
+          </a:bodyPr>
+          <a:lstStyle/>
+          <a:p>
+            <a:pPr indent="0" marL="0">
+              <a:buNone/>
+            </a:pPr>
+            <a:r>
+              <a:rPr lang="en-US" sz="1120" dirty="0">
                 <a:solidFill>
                   <a:srgbClr val="18221F"/>
                 </a:solidFill>
               </a:rPr>
-              <a:t>migration smoke</a:t>
+              <a:t>migration checks for PostgreSQL-compatible storage</a:t>
             </a:r>
-            <a:endParaRPr lang="en-US" sz="1200" dirty="0"/>
+            <a:endParaRPr lang="en-US" sz="1120" dirty="0"/>
           </a:p>
         </p:txBody>
       </p:sp>
       <p:sp>
         <p:nvSpPr>
-          <p:cNvPr id="51" name="Shape 49"/>
-          <p:cNvSpPr/>
-          <p:nvPr/>
-        </p:nvSpPr>
-        <p:spPr>
-          <a:xfrm>
-            <a:off x="2606040" y="3922776"/>
-            <a:ext cx="6858000" cy="164592"/>
+          <p:cNvPr id="56" name="Shape 54"/>
+          <p:cNvSpPr/>
+          <p:nvPr/>
+        </p:nvSpPr>
+        <p:spPr>
+          <a:xfrm>
+            <a:off x="5349240" y="3749040"/>
+            <a:ext cx="3977640" cy="896112"/>
           </a:xfrm>
           <a:prstGeom prst="rect">
             <a:avLst/>
           </a:prstGeom>
           <a:solidFill>
-            <a:srgbClr val="E8EEE9"/>
+            <a:srgbClr val="FFFFFF"/>
+          </a:solidFill>
+          <a:ln w="13970">
+            <a:solidFill>
+              <a:srgbClr val="D85F4B"/>
+            </a:solidFill>
+            <a:prstDash val="solid"/>
+          </a:ln>
+        </p:spPr>
+      </p:sp>
+      <p:sp>
+        <p:nvSpPr>
+          <p:cNvPr id="57" name="Shape 55"/>
+          <p:cNvSpPr/>
+          <p:nvPr/>
+        </p:nvSpPr>
+        <p:spPr>
+          <a:xfrm>
+            <a:off x="5349240" y="3749040"/>
+            <a:ext cx="118872" cy="896112"/>
+          </a:xfrm>
+          <a:prstGeom prst="rect">
+            <a:avLst/>
+          </a:prstGeom>
+          <a:solidFill>
+            <a:srgbClr val="D85F4B"/>
           </a:solidFill>
           <a:ln w="12700">
             <a:solidFill>
-              <a:srgbClr val="E8EEE9"/>
-            </a:solidFill>
-            <a:prstDash val="solid"/>
-          </a:ln>
-        </p:spPr>
-      </p:sp>
-      <p:sp>
-        <p:nvSpPr>
-          <p:cNvPr id="52" name="Shape 50"/>
-          <p:cNvSpPr/>
-          <p:nvPr/>
-        </p:nvSpPr>
-        <p:spPr>
-          <a:xfrm>
-            <a:off x="2606040" y="3922776"/>
-            <a:ext cx="4937760" cy="164592"/>
-          </a:xfrm>
-          <a:prstGeom prst="rect">
-            <a:avLst/>
-          </a:prstGeom>
-          <a:solidFill>
-            <a:srgbClr val="E6A83B"/>
-          </a:solidFill>
-          <a:ln w="12700">
-            <a:solidFill>
-              <a:srgbClr val="E6A83B"/>
-            </a:solidFill>
-            <a:prstDash val="solid"/>
-          </a:ln>
-        </p:spPr>
-      </p:sp>
-      <p:sp>
-        <p:nvSpPr>
-          <p:cNvPr id="53" name="Text 51"/>
-          <p:cNvSpPr/>
-          <p:nvPr/>
-        </p:nvSpPr>
-        <p:spPr>
-          <a:xfrm>
-            <a:off x="914400" y="4553712"/>
-            <a:ext cx="1417320" cy="182880"/>
+              <a:srgbClr val="D85F4B"/>
+            </a:solidFill>
+            <a:prstDash val="solid"/>
+          </a:ln>
+        </p:spPr>
+      </p:sp>
+      <p:sp>
+        <p:nvSpPr>
+          <p:cNvPr id="58" name="Text 56"/>
+          <p:cNvSpPr/>
+          <p:nvPr/>
+        </p:nvSpPr>
+        <p:spPr>
+          <a:xfrm>
+            <a:off x="5623560" y="3913632"/>
+            <a:ext cx="1325880" cy="182880"/>
           </a:xfrm>
           <a:prstGeom prst="rect">
             <a:avLst/>
@@ -15091,77 +15255,65 @@
               <a:buNone/>
             </a:pPr>
             <a:r>
-              <a:rPr lang="en-US" sz="1200" b="1" dirty="0">
+              <a:rPr lang="en-US" sz="1250" b="1" dirty="0">
+                <a:solidFill>
+                  <a:srgbClr val="D85F4B"/>
+                </a:solidFill>
+              </a:rPr>
+              <a:t>Delivery</a:t>
+            </a:r>
+            <a:endParaRPr lang="en-US" sz="1250" dirty="0"/>
+          </a:p>
+        </p:txBody>
+      </p:sp>
+      <p:sp>
+        <p:nvSpPr>
+          <p:cNvPr id="59" name="Text 57"/>
+          <p:cNvSpPr/>
+          <p:nvPr/>
+        </p:nvSpPr>
+        <p:spPr>
+          <a:xfrm>
+            <a:off x="6922008" y="3913632"/>
+            <a:ext cx="2148840" cy="384048"/>
+          </a:xfrm>
+          <a:prstGeom prst="rect">
+            <a:avLst/>
+          </a:prstGeom>
+          <a:noFill/>
+          <a:ln/>
+        </p:spPr>
+        <p:txBody>
+          <a:bodyPr wrap="square" lIns="0" tIns="0" rIns="0" bIns="0" rtlCol="0" anchor="ctr">
+            <a:normAutofit/>
+          </a:bodyPr>
+          <a:lstStyle/>
+          <a:p>
+            <a:pPr indent="0" marL="0">
+              <a:buNone/>
+            </a:pPr>
+            <a:r>
+              <a:rPr lang="en-US" sz="1120" dirty="0">
                 <a:solidFill>
                   <a:srgbClr val="18221F"/>
                 </a:solidFill>
               </a:rPr>
-              <a:t>frontend checks</a:t>
+              <a:t>TypeScript, lint, Vite, Playwright, GitHub CI, Railway</a:t>
             </a:r>
-            <a:endParaRPr lang="en-US" sz="1200" dirty="0"/>
+            <a:endParaRPr lang="en-US" sz="1120" dirty="0"/>
           </a:p>
         </p:txBody>
       </p:sp>
       <p:sp>
         <p:nvSpPr>
-          <p:cNvPr id="54" name="Shape 52"/>
-          <p:cNvSpPr/>
-          <p:nvPr/>
-        </p:nvSpPr>
-        <p:spPr>
-          <a:xfrm>
-            <a:off x="2606040" y="4581144"/>
-            <a:ext cx="6858000" cy="164592"/>
-          </a:xfrm>
-          <a:prstGeom prst="rect">
-            <a:avLst/>
-          </a:prstGeom>
-          <a:solidFill>
-            <a:srgbClr val="E8EEE9"/>
-          </a:solidFill>
-          <a:ln w="12700">
-            <a:solidFill>
-              <a:srgbClr val="E8EEE9"/>
-            </a:solidFill>
-            <a:prstDash val="solid"/>
-          </a:ln>
-        </p:spPr>
-      </p:sp>
-      <p:sp>
-        <p:nvSpPr>
-          <p:cNvPr id="55" name="Shape 53"/>
-          <p:cNvSpPr/>
-          <p:nvPr/>
-        </p:nvSpPr>
-        <p:spPr>
-          <a:xfrm>
-            <a:off x="2606040" y="4581144"/>
-            <a:ext cx="5349240" cy="164592"/>
-          </a:xfrm>
-          <a:prstGeom prst="rect">
-            <a:avLst/>
-          </a:prstGeom>
-          <a:solidFill>
-            <a:srgbClr val="D85F4B"/>
-          </a:solidFill>
-          <a:ln w="12700">
-            <a:solidFill>
-              <a:srgbClr val="D85F4B"/>
-            </a:solidFill>
-            <a:prstDash val="solid"/>
-          </a:ln>
-        </p:spPr>
-      </p:sp>
-      <p:sp>
-        <p:nvSpPr>
-          <p:cNvPr id="56" name="Shape 54"/>
-          <p:cNvSpPr/>
-          <p:nvPr/>
-        </p:nvSpPr>
-        <p:spPr>
-          <a:xfrm>
-            <a:off x="9875520" y="2578608"/>
-            <a:ext cx="1371600" cy="2788920"/>
+          <p:cNvPr id="60" name="Shape 58"/>
+          <p:cNvSpPr/>
+          <p:nvPr/>
+        </p:nvSpPr>
+        <p:spPr>
+          <a:xfrm>
+            <a:off x="822960" y="5138928"/>
+            <a:ext cx="10424160" cy="530352"/>
           </a:xfrm>
           <a:prstGeom prst="rect">
             <a:avLst/>
@@ -15179,14 +15331,14 @@
       </p:sp>
       <p:sp>
         <p:nvSpPr>
-          <p:cNvPr id="57" name="Text 55"/>
-          <p:cNvSpPr/>
-          <p:nvPr/>
-        </p:nvSpPr>
-        <p:spPr>
-          <a:xfrm>
-            <a:off x="10058400" y="2880360"/>
-            <a:ext cx="1005840" cy="182880"/>
+          <p:cNvPr id="61" name="Text 59"/>
+          <p:cNvSpPr/>
+          <p:nvPr/>
+        </p:nvSpPr>
+        <p:spPr>
+          <a:xfrm>
+            <a:off x="1051560" y="5321808"/>
+            <a:ext cx="960120" cy="146304"/>
           </a:xfrm>
           <a:prstGeom prst="rect">
             <a:avLst/>
@@ -15198,7 +15350,7 @@
           <a:bodyPr wrap="square" lIns="0" tIns="0" rIns="0" bIns="0" rtlCol="0" anchor="ctr"/>
           <a:lstStyle/>
           <a:p>
-            <a:pPr algn="ctr" indent="0" marL="0">
+            <a:pPr indent="0" marL="0">
               <a:buNone/>
             </a:pPr>
             <a:r>
@@ -15215,14 +15367,14 @@
       </p:sp>
       <p:sp>
         <p:nvSpPr>
-          <p:cNvPr id="58" name="Text 56"/>
-          <p:cNvSpPr/>
-          <p:nvPr/>
-        </p:nvSpPr>
-        <p:spPr>
-          <a:xfrm>
-            <a:off x="10040112" y="3401568"/>
-            <a:ext cx="1051560" cy="914400"/>
+          <p:cNvPr id="62" name="Text 60"/>
+          <p:cNvSpPr/>
+          <p:nvPr/>
+        </p:nvSpPr>
+        <p:spPr>
+          <a:xfrm>
+            <a:off x="2240280" y="5294376"/>
+            <a:ext cx="8046720" cy="182880"/>
           </a:xfrm>
           <a:prstGeom prst="rect">
             <a:avLst/>
@@ -15236,18 +15388,18 @@
           </a:bodyPr>
           <a:lstStyle/>
           <a:p>
-            <a:pPr algn="ctr" indent="0" marL="0">
+            <a:pPr indent="0" marL="0">
               <a:buNone/>
             </a:pPr>
             <a:r>
-              <a:rPr lang="en-US" sz="1250" b="1" dirty="0">
+              <a:rPr lang="en-US" sz="1200" b="1" dirty="0">
                 <a:solidFill>
                   <a:srgbClr val="F6F1E7"/>
                 </a:solidFill>
               </a:rPr>
               <a:t>Tests prove contracts, not production load.</a:t>
             </a:r>
-            <a:endParaRPr lang="en-US" sz="1250" dirty="0"/>
+            <a:endParaRPr lang="en-US" sz="1200" dirty="0"/>
           </a:p>
         </p:txBody>
       </p:sp>
@@ -16314,7 +16466,7 @@
                   <a:srgbClr val="8BD8B0"/>
                 </a:solidFill>
               </a:rPr>
-              <a:t>LIVE DEMO CONTRACT</a:t>
+              <a:t>LIVE DEMO</a:t>
             </a:r>
             <a:endParaRPr lang="en-US" sz="1000" dirty="0"/>
           </a:p>
@@ -16355,7 +16507,7 @@
                 <a:ea typeface="Aptos Display" pitchFamily="34" charset="-122"/>
                 <a:cs typeface="Aptos Display" pitchFamily="34" charset="-120"/>
               </a:rPr>
-              <a:t>The live demo follows the same path</a:t>
+              <a:t>We will follow one user through the system</a:t>
             </a:r>
             <a:endParaRPr lang="en-US" sz="2900" dirty="0"/>
           </a:p>
@@ -16393,7 +16545,7 @@
                   <a:srgbClr val="AEBFB6"/>
                 </a:solidFill>
               </a:rPr>
-              <a:t>Show the normal planning flow, one safe failure, and the engineering evidence.</a:t>
+              <a:t>Registration, setup, plan creation, a rejected import, seeded data, and a snapshot-backed explanation.</a:t>
             </a:r>
             <a:endParaRPr lang="en-US" sz="1300" dirty="0"/>
           </a:p>
@@ -16831,6 +16983,42 @@
               <a:t>Deck stops here. Product proof starts in the browser.</a:t>
             </a:r>
             <a:endParaRPr lang="en-US" sz="1900" dirty="0"/>
+          </a:p>
+        </p:txBody>
+      </p:sp>
+      <p:sp>
+        <p:nvSpPr>
+          <p:cNvPr id="57" name="Text 55"/>
+          <p:cNvSpPr/>
+          <p:nvPr/>
+        </p:nvSpPr>
+        <p:spPr>
+          <a:xfrm>
+            <a:off x="987552" y="5925312"/>
+            <a:ext cx="9966960" cy="164592"/>
+          </a:xfrm>
+          <a:prstGeom prst="rect">
+            <a:avLst/>
+          </a:prstGeom>
+          <a:noFill/>
+          <a:ln/>
+        </p:spPr>
+        <p:txBody>
+          <a:bodyPr wrap="square" lIns="0" tIns="0" rIns="0" bIns="0" rtlCol="0" anchor="ctr"/>
+          <a:lstStyle/>
+          <a:p>
+            <a:pPr algn="ctr" indent="0" marL="0">
+              <a:buNone/>
+            </a:pPr>
+            <a:r>
+              <a:rPr lang="en-US" sz="1050" dirty="0">
+                <a:solidFill>
+                  <a:srgbClr val="AEBFB6"/>
+                </a:solidFill>
+              </a:rPr>
+              <a:t>goalwise.up.railway.app/register  |  staging-goalwise.up.railway.app/register</a:t>
+            </a:r>
+            <a:endParaRPr lang="en-US" sz="1050" dirty="0"/>
           </a:p>
         </p:txBody>
       </p:sp>

</xml_diff>